<commit_message>
App e presentazione: domande e slide sul filo del discorso
App di allenamento: nuova area "Il filo del discorso" con 11 domande e
2 punti deboli. Presentazione: due slide nuove (la mappa e la modalità
Presenta), screenshot dell'app aggiornato, testi di copertina, routine e
"Dove trovarli" aggiornati. ISTRUZIONI.md: nuova sezione.

Co-Authored-By: Claude Opus 5.5 <noreply@anthropic.com>
Claude-Session: https://claude.ai/code/session_01Qx7dyC4F5xdfd7vLgWqzEF
</commit_message>
<xml_diff>
--- a/presentazione/come-usare-la-mappa.pptx
+++ b/presentazione/come-usare-la-mappa.pptx
@@ -14,6 +14,8 @@
     <p:sldId id="262" r:id="rId8"/>
     <p:sldId id="263" r:id="rId9"/>
     <p:sldId id="264" r:id="rId10"/>
+    <p:sldId id="267" r:id="rId18"/>
+    <p:sldId id="268" r:id="rId19"/>
     <p:sldId id="265" r:id="rId11"/>
     <p:sldId id="266" r:id="rId12"/>
   </p:sldIdLst>
@@ -2141,7 +2143,7 @@
                   <a:schemeClr val="accent2"/>
                 </a:solidFill>
               </a:rPr>
-              <a:t>Due strumenti per ripassare in vista dell'orale di dottorato: la mappa concettuale e l'allenamento alle domande</a:t>
+              <a:t>Per l'orale di dottorato: la mappa dei post-it, l'allenamento alle domande e Il filo del discorso per presentare il progetto</a:t>
             </a:r>
             <a:endParaRPr lang="en-US" sz="2000" dirty="0"/>
           </a:p>
@@ -2553,7 +2555,7 @@
                   <a:srgbClr val="1F1A17"/>
                 </a:solidFill>
               </a:rPr>
-              <a:t>Nell'app, scheda Interrogami, con il timer.</a:t>
+              <a:t>Nell'app, scheda Interrogami. Poi una prova del discorso in modalità Presenta.</a:t>
             </a:r>
             <a:endParaRPr lang="en-US" sz="1600" dirty="0"/>
           </a:p>
@@ -2681,7 +2683,7 @@
             <a:pPr algn="l"/>
             <a:fld id="{F7021451-1387-4CA6-816F-3879F97B5CBC}" type="slidenum">
               <a:rPr b="0" lang="en-US"/>
-              <a:t>10</a:t>
+              <a:t>12</a:t>
             </a:fld>
             <a:endParaRPr lang="en-US"/>
           </a:p>
@@ -2782,9 +2784,880 @@
                   <a:schemeClr val="accent2"/>
                 </a:solidFill>
               </a:rPr>
-              <a:t>Su GitHub (vignini/sentiment) nella cartella docs, con i link nel README, e come pagine su claude.ai. Le istruzioni complete sono in ISTRUZIONI.md.</a:t>
+              <a:t>Sul sito vignini.github.io/sentiment, con un indice in due sezioni: il progetto di dottorato e il ripasso per l'orale. I file sono su GitHub (vignini/sentiment) nella cartella docs. Le istruzioni complete sono in ISTRUZIONI.md.</a:t>
             </a:r>
             <a:endParaRPr lang="en-US" sz="2000" dirty="0"/>
+          </a:p>
+        </p:txBody>
+      </p:sp>
+    </p:spTree>
+  </p:cSld>
+  <p:clrMapOvr>
+    <a:masterClrMapping/>
+  </p:clrMapOvr>
+</p:sld>
+</file>
+
+<file path=ppt/slides/slide12.xml><?xml version="1.0" encoding="utf-8"?>
+<p:sld xmlns:a="http://schemas.openxmlformats.org/drawingml/2006/main" xmlns:r="http://schemas.openxmlformats.org/officeDocument/2006/relationships" xmlns:p="http://schemas.openxmlformats.org/presentationml/2006/main">
+  <p:cSld name="Slide 3">
+    <p:spTree>
+      <p:nvGrpSpPr>
+        <p:cNvPr id="1" name=""/>
+        <p:cNvGrpSpPr/>
+        <p:nvPr/>
+      </p:nvGrpSpPr>
+      <p:grpSpPr>
+        <a:xfrm>
+          <a:off x="0" y="0"/>
+          <a:ext cx="0" cy="0"/>
+          <a:chOff x="0" y="0"/>
+          <a:chExt cx="0" cy="0"/>
+        </a:xfrm>
+      </p:grpSpPr>
+      <p:sp>
+        <p:nvSpPr>
+          <p:cNvPr id="2" name="Text 0"/>
+          <p:cNvSpPr/>
+          <p:nvPr>
+            <p:ph idx="100" type="title" hasCustomPrompt="1"/>
+          </p:nvPr>
+        </p:nvSpPr>
+        <p:spPr>
+          <a:xfrm>
+            <a:off x="548640" y="365760"/>
+            <a:ext cx="11064240" cy="822960"/>
+          </a:xfrm>
+          <a:prstGeom prst="rect">
+            <a:avLst/>
+          </a:prstGeom>
+          <a:noFill/>
+          <a:ln/>
+        </p:spPr>
+        <p:txBody>
+          <a:bodyPr wrap="square" lIns="0" tIns="0" rIns="0" bIns="0" rtlCol="0" anchor="ctr"/>
+          <a:lstStyle/>
+          <a:p>
+            <a:pPr indent="0" marL="0">
+              <a:buNone/>
+            </a:pPr>
+            <a:r>
+              <a:rPr lang="en-US" sz="3600" b="1" dirty="0">
+                <a:solidFill>
+                  <a:schemeClr val="tx2"/>
+                </a:solidFill>
+              </a:rPr>
+              <a:t>Il filo del discorso: la mappa per presentare</a:t>
+            </a:r>
+            <a:endParaRPr lang="en-US" sz="3600" dirty="0"/>
+          </a:p>
+        </p:txBody>
+      </p:sp>
+      <p:sp>
+        <p:nvSpPr>
+          <p:cNvPr id="3" name="img-map2-frame"/>
+          <p:cNvSpPr/>
+          <p:nvPr/>
+        </p:nvSpPr>
+        <p:spPr>
+          <a:xfrm>
+            <a:off x="512064" y="1380744"/>
+            <a:ext cx="6839712" cy="3615710"/>
+          </a:xfrm>
+          <a:prstGeom prst="rect">
+            <a:avLst/>
+          </a:prstGeom>
+          <a:solidFill>
+            <a:srgbClr val="E6E1DA"/>
+          </a:solidFill>
+          <a:ln/>
+        </p:spPr>
+      </p:sp>
+      <p:pic>
+        <p:nvPicPr>
+          <p:cNvPr id="4" name="img-map2" descr="map.png">    </p:cNvPr>
+          <p:cNvPicPr>
+            <a:picLocks noChangeAspect="1"/>
+          </p:cNvPicPr>
+          <p:nvPr/>
+        </p:nvPicPr>
+        <p:blipFill>
+          <a:blip r:embed="rId1"/>
+          <a:stretch>
+            <a:fillRect/>
+          </a:stretch>
+        </p:blipFill>
+        <p:spPr>
+          <a:xfrm>
+            <a:off x="548640" y="1417320"/>
+            <a:ext cx="6766560" cy="3542558"/>
+          </a:xfrm>
+          <a:prstGeom prst="rect">
+            <a:avLst/>
+          </a:prstGeom>
+        </p:spPr>
+      </p:pic>
+      <p:sp>
+        <p:nvSpPr>
+          <p:cNvPr id="5" name="n3-bg"/>
+          <p:cNvSpPr/>
+          <p:nvPr/>
+        </p:nvSpPr>
+        <p:spPr>
+          <a:xfrm>
+            <a:off x="7680960" y="1417320"/>
+            <a:ext cx="3931920" cy="1325880"/>
+          </a:xfrm>
+          <a:prstGeom prst="rect">
+            <a:avLst/>
+          </a:prstGeom>
+          <a:solidFill>
+            <a:srgbClr val="F6E7A1"/>
+          </a:solidFill>
+          <a:ln/>
+          <a:effectLst>
+            <a:outerShdw sx="100000" sy="100000" kx="0" ky="0" algn="bl" rotWithShape="0" blurRad="76200" dist="25400" dir="5400000">
+              <a:srgbClr val="000000">
+                <a:alpha val="18000"/>
+              </a:srgbClr>
+            </a:outerShdw>
+          </a:effectLst>
+        </p:spPr>
+      </p:sp>
+      <p:sp>
+        <p:nvSpPr>
+          <p:cNvPr id="6" name="n3"/>
+          <p:cNvSpPr txBox="1"/>
+          <p:nvPr/>
+        </p:nvSpPr>
+        <p:spPr>
+          <a:xfrm>
+            <a:off x="7818120" y="1527048"/>
+            <a:ext cx="3657600" cy="1106424"/>
+          </a:xfrm>
+          <a:prstGeom prst="rect">
+            <a:avLst/>
+          </a:prstGeom>
+          <a:noFill/>
+          <a:ln/>
+        </p:spPr>
+        <p:txBody>
+          <a:bodyPr wrap="square" lIns="0" tIns="0" rIns="0" bIns="0" rtlCol="0" anchor="t"/>
+          <a:lstStyle/>
+          <a:p>
+            <a:pPr indent="0" marL="0">
+              <a:spcAft>
+                <a:spcPts val="400"/>
+              </a:spcAft>
+              <a:buNone/>
+            </a:pPr>
+            <a:r>
+              <a:rPr lang="en-US" sz="1600" b="1" dirty="0">
+                <a:solidFill>
+                  <a:srgbClr val="1F1A17"/>
+                </a:solidFill>
+              </a:rPr>
+              <a:t>12 tappe in 4 atti</a:t>
+            </a:r>
+            <a:endParaRPr lang="en-US" sz="1600" dirty="0"/>
+          </a:p>
+          <a:p>
+            <a:pPr indent="0" marL="0">
+              <a:spcAft>
+                <a:spcPts val="400"/>
+              </a:spcAft>
+              <a:buNone/>
+            </a:pPr>
+            <a:r>
+              <a:rPr lang="en-US" sz="1400" dirty="0">
+                <a:solidFill>
+                  <a:srgbClr val="1F1A17"/>
+                </a:solidFill>
+              </a:rPr>
+              <a:t>Dalla storia di West Pokot alla domanda finale. I numeri in alto portano alla tappa.</a:t>
+            </a:r>
+            <a:endParaRPr lang="en-US" sz="1600" dirty="0"/>
+          </a:p>
+        </p:txBody>
+      </p:sp>
+      <p:sp>
+        <p:nvSpPr>
+          <p:cNvPr id="7" name="n4-bg"/>
+          <p:cNvSpPr/>
+          <p:nvPr/>
+        </p:nvSpPr>
+        <p:spPr>
+          <a:xfrm>
+            <a:off x="7680960" y="2971800"/>
+            <a:ext cx="3931920" cy="1325880"/>
+          </a:xfrm>
+          <a:prstGeom prst="rect">
+            <a:avLst/>
+          </a:prstGeom>
+          <a:solidFill>
+            <a:srgbClr val="F7A8C4"/>
+          </a:solidFill>
+          <a:ln/>
+          <a:effectLst>
+            <a:outerShdw sx="100000" sy="100000" kx="0" ky="0" algn="bl" rotWithShape="0" blurRad="76200" dist="25400" dir="5400000">
+              <a:srgbClr val="000000">
+                <a:alpha val="18000"/>
+              </a:srgbClr>
+            </a:outerShdw>
+          </a:effectLst>
+        </p:spPr>
+      </p:sp>
+      <p:sp>
+        <p:nvSpPr>
+          <p:cNvPr id="8" name="n4"/>
+          <p:cNvSpPr txBox="1"/>
+          <p:nvPr/>
+        </p:nvSpPr>
+        <p:spPr>
+          <a:xfrm>
+            <a:off x="7818120" y="3081528"/>
+            <a:ext cx="3657600" cy="1106424"/>
+          </a:xfrm>
+          <a:prstGeom prst="rect">
+            <a:avLst/>
+          </a:prstGeom>
+          <a:noFill/>
+          <a:ln/>
+        </p:spPr>
+        <p:txBody>
+          <a:bodyPr wrap="square" lIns="0" tIns="0" rIns="0" bIns="0" rtlCol="0" anchor="t"/>
+          <a:lstStyle/>
+          <a:p>
+            <a:pPr indent="0" marL="0">
+              <a:spcAft>
+                <a:spcPts val="400"/>
+              </a:spcAft>
+              <a:buNone/>
+            </a:pPr>
+            <a:r>
+              <a:rPr lang="en-US" sz="1600" b="1" dirty="0">
+                <a:solidFill>
+                  <a:srgbClr val="1F1A17"/>
+                </a:solidFill>
+              </a:rPr>
+              <a:t>Cosa dire e frase-ponte</a:t>
+            </a:r>
+            <a:endParaRPr lang="en-US" sz="1600" dirty="0"/>
+          </a:p>
+          <a:p>
+            <a:pPr indent="0" marL="0">
+              <a:spcAft>
+                <a:spcPts val="400"/>
+              </a:spcAft>
+              <a:buNone/>
+            </a:pPr>
+            <a:r>
+              <a:rPr lang="en-US" sz="1400" dirty="0">
+                <a:solidFill>
+                  <a:srgbClr val="1F1A17"/>
+                </a:solidFill>
+              </a:rPr>
+              <a:t>Per ogni tappa: testo, parole chiave, la frase che porta alla tappa dopo e "Se ti chiedono…".</a:t>
+            </a:r>
+            <a:endParaRPr lang="en-US" sz="1600" dirty="0"/>
+          </a:p>
+        </p:txBody>
+      </p:sp>
+      <p:sp>
+        <p:nvSpPr>
+          <p:cNvPr id="9" name="n5-bg"/>
+          <p:cNvSpPr/>
+          <p:nvPr/>
+        </p:nvSpPr>
+        <p:spPr>
+          <a:xfrm>
+            <a:off x="7680960" y="4526280"/>
+            <a:ext cx="3931920" cy="1325880"/>
+          </a:xfrm>
+          <a:prstGeom prst="rect">
+            <a:avLst/>
+          </a:prstGeom>
+          <a:solidFill>
+            <a:srgbClr val="D9C6F2"/>
+          </a:solidFill>
+          <a:ln/>
+          <a:effectLst>
+            <a:outerShdw sx="100000" sy="100000" kx="0" ky="0" algn="bl" rotWithShape="0" blurRad="76200" dist="25400" dir="5400000">
+              <a:srgbClr val="000000">
+                <a:alpha val="18000"/>
+              </a:srgbClr>
+            </a:outerShdw>
+          </a:effectLst>
+        </p:spPr>
+      </p:sp>
+      <p:sp>
+        <p:nvSpPr>
+          <p:cNvPr id="10" name="n5"/>
+          <p:cNvSpPr txBox="1"/>
+          <p:nvPr/>
+        </p:nvSpPr>
+        <p:spPr>
+          <a:xfrm>
+            <a:off x="7818120" y="4636008"/>
+            <a:ext cx="3657600" cy="1106424"/>
+          </a:xfrm>
+          <a:prstGeom prst="rect">
+            <a:avLst/>
+          </a:prstGeom>
+          <a:noFill/>
+          <a:ln/>
+        </p:spPr>
+        <p:txBody>
+          <a:bodyPr wrap="square" lIns="0" tIns="0" rIns="0" bIns="0" rtlCol="0" anchor="t"/>
+          <a:lstStyle/>
+          <a:p>
+            <a:pPr indent="0" marL="0">
+              <a:spcAft>
+                <a:spcPts val="400"/>
+              </a:spcAft>
+              <a:buNone/>
+            </a:pPr>
+            <a:r>
+              <a:rPr lang="en-US" sz="1600" b="1" dirty="0">
+                <a:solidFill>
+                  <a:srgbClr val="1F1A17"/>
+                </a:solidFill>
+              </a:rPr>
+              <a:t>Post-it lilla tratteggiati</a:t>
+            </a:r>
+            <a:endParaRPr lang="en-US" sz="1600" dirty="0"/>
+          </a:p>
+          <a:p>
+            <a:pPr indent="0" marL="0">
+              <a:spcAft>
+                <a:spcPts val="400"/>
+              </a:spcAft>
+              <a:buNone/>
+            </a:pPr>
+            <a:r>
+              <a:rPr lang="en-US" sz="1400" dirty="0">
+                <a:solidFill>
+                  <a:srgbClr val="1F1A17"/>
+                </a:solidFill>
+              </a:rPr>
+              <a:t>Sono proposte di Claude: riscrivili con parole tue.</a:t>
+            </a:r>
+            <a:endParaRPr lang="en-US" sz="1600" dirty="0"/>
+          </a:p>
+        </p:txBody>
+      </p:sp>
+      <p:sp>
+        <p:nvSpPr>
+          <p:cNvPr id="25" name="Slide Number Placeholder 0"/>
+          <p:cNvSpPr>
+            <a:spLocks noGrp="1"/>
+          </p:cNvSpPr>
+          <p:nvPr>
+            <p:ph type="sldNum" sz="quarter" idx="4294967295"/>
+          </p:nvPr>
+        </p:nvSpPr>
+        <p:spPr>
+          <a:xfrm>
+            <a:off x="11430000" y="6400800"/>
+            <a:ext cx="457200" cy="274320"/>
+          </a:xfrm>
+          <a:prstGeom prst="rect">
+            <a:avLst/>
+          </a:prstGeom>
+          <a:extLst>
+            <a:ext uri="{C572A759-6A51-4108-AA02-DFA0A04FC94B}">
+              <ma14:wrappingTextBoxFlag xmlns:ma14="http://schemas.microsoft.com/office/mac/drawingml/2011/main" val="0"/>
+            </a:ext>
+          </a:extLst>
+        </p:spPr>
+        <p:txBody>
+          <a:bodyPr/>
+          <a:lstStyle>
+            <a:lvl1pPr>
+              <a:defRPr sz="1000">
+                <a:solidFill>
+                  <a:srgbClr val="6B645D"/>
+                </a:solidFill>
+              </a:defRPr>
+            </a:lvl1pPr>
+          </a:lstStyle>
+          <a:p>
+            <a:pPr algn="l"/>
+            <a:fld id="{F7021451-1387-4CA6-816F-3879F97B5CBC}" type="slidenum">
+              <a:rPr b="0" lang="en-US"/>
+              <a:t>10</a:t>
+            </a:fld>
+            <a:endParaRPr lang="en-US"/>
+          </a:p>
+        </p:txBody>
+      </p:sp>
+    </p:spTree>
+  </p:cSld>
+  <p:clrMapOvr>
+    <a:masterClrMapping/>
+  </p:clrMapOvr>
+</p:sld>
+</file>
+
+<file path=ppt/slides/slide13.xml><?xml version="1.0" encoding="utf-8"?>
+<p:sld xmlns:a="http://schemas.openxmlformats.org/drawingml/2006/main" xmlns:r="http://schemas.openxmlformats.org/officeDocument/2006/relationships" xmlns:p="http://schemas.openxmlformats.org/presentationml/2006/main">
+  <p:cSld name="Slide 6">
+    <p:spTree>
+      <p:nvGrpSpPr>
+        <p:cNvPr id="1" name=""/>
+        <p:cNvGrpSpPr/>
+        <p:nvPr/>
+      </p:nvGrpSpPr>
+      <p:grpSpPr>
+        <a:xfrm>
+          <a:off x="0" y="0"/>
+          <a:ext cx="0" cy="0"/>
+          <a:chOff x="0" y="0"/>
+          <a:chExt cx="0" cy="0"/>
+        </a:xfrm>
+      </p:grpSpPr>
+      <p:sp>
+        <p:nvSpPr>
+          <p:cNvPr id="2" name="Text 0"/>
+          <p:cNvSpPr/>
+          <p:nvPr>
+            <p:ph idx="100" type="title" hasCustomPrompt="1"/>
+          </p:nvPr>
+        </p:nvSpPr>
+        <p:spPr>
+          <a:xfrm>
+            <a:off x="548640" y="365760"/>
+            <a:ext cx="11064240" cy="822960"/>
+          </a:xfrm>
+          <a:prstGeom prst="rect">
+            <a:avLst/>
+          </a:prstGeom>
+          <a:noFill/>
+          <a:ln/>
+        </p:spPr>
+        <p:txBody>
+          <a:bodyPr wrap="square" lIns="0" tIns="0" rIns="0" bIns="0" rtlCol="0" anchor="ctr"/>
+          <a:lstStyle/>
+          <a:p>
+            <a:pPr indent="0" marL="0">
+              <a:buNone/>
+            </a:pPr>
+            <a:r>
+              <a:rPr lang="en-US" sz="3600" b="1" dirty="0">
+                <a:solidFill>
+                  <a:schemeClr val="tx2"/>
+                </a:solidFill>
+              </a:rPr>
+              <a:t>Modalità Presenta: provare il discorso</a:t>
+            </a:r>
+            <a:endParaRPr lang="en-US" sz="3600" dirty="0"/>
+          </a:p>
+        </p:txBody>
+      </p:sp>
+      <p:sp>
+        <p:nvSpPr>
+          <p:cNvPr id="3" name="img-study-frame"/>
+          <p:cNvSpPr/>
+          <p:nvPr/>
+        </p:nvSpPr>
+        <p:spPr>
+          <a:xfrm>
+            <a:off x="4809744" y="1380744"/>
+            <a:ext cx="6839712" cy="4302252"/>
+          </a:xfrm>
+          <a:prstGeom prst="rect">
+            <a:avLst/>
+          </a:prstGeom>
+          <a:solidFill>
+            <a:srgbClr val="E6E1DA"/>
+          </a:solidFill>
+          <a:ln/>
+        </p:spPr>
+      </p:sp>
+      <p:pic>
+        <p:nvPicPr>
+          <p:cNvPr id="4" name="img-study" descr="study.png">    </p:cNvPr>
+          <p:cNvPicPr>
+            <a:picLocks noChangeAspect="1"/>
+          </p:cNvPicPr>
+          <p:nvPr/>
+        </p:nvPicPr>
+        <p:blipFill>
+          <a:blip r:embed="rId1"/>
+          <a:stretch>
+            <a:fillRect/>
+          </a:stretch>
+        </p:blipFill>
+        <p:spPr>
+          <a:xfrm>
+            <a:off x="4846320" y="1417320"/>
+            <a:ext cx="6766560" cy="4229100"/>
+          </a:xfrm>
+          <a:prstGeom prst="rect">
+            <a:avLst/>
+          </a:prstGeom>
+        </p:spPr>
+      </p:pic>
+      <p:sp>
+        <p:nvSpPr>
+          <p:cNvPr id="5" name="step-1"/>
+          <p:cNvSpPr/>
+          <p:nvPr/>
+        </p:nvSpPr>
+        <p:spPr>
+          <a:xfrm>
+            <a:off x="548640" y="1417320"/>
+            <a:ext cx="640080" cy="640080"/>
+          </a:xfrm>
+          <a:prstGeom prst="ellipse">
+            <a:avLst/>
+          </a:prstGeom>
+          <a:solidFill>
+            <a:schemeClr val="accent1"/>
+          </a:solidFill>
+          <a:ln/>
+        </p:spPr>
+      </p:sp>
+      <p:sp>
+        <p:nvSpPr>
+          <p:cNvPr id="6" name="stepn-1"/>
+          <p:cNvSpPr txBox="1"/>
+          <p:nvPr/>
+        </p:nvSpPr>
+        <p:spPr>
+          <a:xfrm>
+            <a:off x="548640" y="1417320"/>
+            <a:ext cx="640080" cy="640080"/>
+          </a:xfrm>
+          <a:prstGeom prst="rect">
+            <a:avLst/>
+          </a:prstGeom>
+          <a:noFill/>
+          <a:ln/>
+        </p:spPr>
+        <p:txBody>
+          <a:bodyPr wrap="square" lIns="0" tIns="0" rIns="0" bIns="0" rtlCol="0" anchor="ctr"/>
+          <a:lstStyle/>
+          <a:p>
+            <a:pPr algn="ctr" indent="0" marL="0">
+              <a:buNone/>
+            </a:pPr>
+            <a:r>
+              <a:rPr lang="en-US" sz="2200" b="1" dirty="0">
+                <a:solidFill>
+                  <a:schemeClr val="bg1"/>
+                </a:solidFill>
+              </a:rPr>
+              <a:t>1</a:t>
+            </a:r>
+            <a:endParaRPr lang="en-US" sz="2200" dirty="0"/>
+          </a:p>
+        </p:txBody>
+      </p:sp>
+      <p:sp>
+        <p:nvSpPr>
+          <p:cNvPr id="7" name="stept-1"/>
+          <p:cNvSpPr txBox="1"/>
+          <p:nvPr/>
+        </p:nvSpPr>
+        <p:spPr>
+          <a:xfrm>
+            <a:off x="1371600" y="1371600"/>
+            <a:ext cx="3200400" cy="1188720"/>
+          </a:xfrm>
+          <a:prstGeom prst="rect">
+            <a:avLst/>
+          </a:prstGeom>
+          <a:noFill/>
+          <a:ln/>
+        </p:spPr>
+        <p:txBody>
+          <a:bodyPr wrap="square" lIns="0" tIns="0" rIns="0" bIns="0" rtlCol="0" anchor="t"/>
+          <a:lstStyle/>
+          <a:p>
+            <a:pPr indent="0" marL="0">
+              <a:buNone/>
+            </a:pPr>
+            <a:r>
+              <a:rPr lang="en-US" sz="1800" b="1" dirty="0">
+                <a:solidFill>
+                  <a:srgbClr val="000000"/>
+                </a:solidFill>
+              </a:rPr>
+              <a:t>Scegli la durata</a:t>
+            </a:r>
+            <a:endParaRPr lang="en-US" sz="1800" dirty="0"/>
+          </a:p>
+          <a:p>
+            <a:pPr indent="0" marL="0">
+              <a:buNone/>
+            </a:pPr>
+            <a:r>
+              <a:rPr lang="en-US" sz="1400" dirty="0">
+                <a:solidFill>
+                  <a:srgbClr val="6B645D"/>
+                </a:solidFill>
+              </a:rPr>
+              <a:t>5, 10, 15 o 20 minuti: il tempo si divide tra le tappe.</a:t>
+            </a:r>
+            <a:endParaRPr lang="en-US" sz="1800" dirty="0"/>
+          </a:p>
+        </p:txBody>
+      </p:sp>
+      <p:sp>
+        <p:nvSpPr>
+          <p:cNvPr id="8" name="step-2"/>
+          <p:cNvSpPr/>
+          <p:nvPr/>
+        </p:nvSpPr>
+        <p:spPr>
+          <a:xfrm>
+            <a:off x="548640" y="2880360"/>
+            <a:ext cx="640080" cy="640080"/>
+          </a:xfrm>
+          <a:prstGeom prst="ellipse">
+            <a:avLst/>
+          </a:prstGeom>
+          <a:solidFill>
+            <a:schemeClr val="accent1"/>
+          </a:solidFill>
+          <a:ln/>
+        </p:spPr>
+      </p:sp>
+      <p:sp>
+        <p:nvSpPr>
+          <p:cNvPr id="9" name="stepn-2"/>
+          <p:cNvSpPr txBox="1"/>
+          <p:nvPr/>
+        </p:nvSpPr>
+        <p:spPr>
+          <a:xfrm>
+            <a:off x="548640" y="2880360"/>
+            <a:ext cx="640080" cy="640080"/>
+          </a:xfrm>
+          <a:prstGeom prst="rect">
+            <a:avLst/>
+          </a:prstGeom>
+          <a:noFill/>
+          <a:ln/>
+        </p:spPr>
+        <p:txBody>
+          <a:bodyPr wrap="square" lIns="0" tIns="0" rIns="0" bIns="0" rtlCol="0" anchor="ctr"/>
+          <a:lstStyle/>
+          <a:p>
+            <a:pPr algn="ctr" indent="0" marL="0">
+              <a:buNone/>
+            </a:pPr>
+            <a:r>
+              <a:rPr lang="en-US" sz="2200" b="1" dirty="0">
+                <a:solidFill>
+                  <a:schemeClr val="bg1"/>
+                </a:solidFill>
+              </a:rPr>
+              <a:t>2</a:t>
+            </a:r>
+            <a:endParaRPr lang="en-US" sz="2200" dirty="0"/>
+          </a:p>
+        </p:txBody>
+      </p:sp>
+      <p:sp>
+        <p:nvSpPr>
+          <p:cNvPr id="10" name="stept-2"/>
+          <p:cNvSpPr txBox="1"/>
+          <p:nvPr/>
+        </p:nvSpPr>
+        <p:spPr>
+          <a:xfrm>
+            <a:off x="1371600" y="2834640"/>
+            <a:ext cx="3200400" cy="1188720"/>
+          </a:xfrm>
+          <a:prstGeom prst="rect">
+            <a:avLst/>
+          </a:prstGeom>
+          <a:noFill/>
+          <a:ln/>
+        </p:spPr>
+        <p:txBody>
+          <a:bodyPr wrap="square" lIns="0" tIns="0" rIns="0" bIns="0" rtlCol="0" anchor="t"/>
+          <a:lstStyle/>
+          <a:p>
+            <a:pPr indent="0" marL="0">
+              <a:buNone/>
+            </a:pPr>
+            <a:r>
+              <a:rPr lang="en-US" sz="1800" b="1" dirty="0">
+                <a:solidFill>
+                  <a:srgbClr val="000000"/>
+                </a:solidFill>
+              </a:rPr>
+              <a:t>Premi Presenta</a:t>
+            </a:r>
+            <a:endParaRPr lang="en-US" sz="1800" dirty="0"/>
+          </a:p>
+          <a:p>
+            <a:pPr indent="0" marL="0">
+              <a:buNone/>
+            </a:pPr>
+            <a:r>
+              <a:rPr lang="en-US" sz="1400" dirty="0">
+                <a:solidFill>
+                  <a:srgbClr val="6B645D"/>
+                </a:solidFill>
+              </a:rPr>
+              <a:t>Una tappa alla volta, con frecce, swipe o Avanti. Il timer diventa rosso se sfori.</a:t>
+            </a:r>
+            <a:endParaRPr lang="en-US" sz="1800" dirty="0"/>
+          </a:p>
+        </p:txBody>
+      </p:sp>
+      <p:sp>
+        <p:nvSpPr>
+          <p:cNvPr id="11" name="step-3"/>
+          <p:cNvSpPr/>
+          <p:nvPr/>
+        </p:nvSpPr>
+        <p:spPr>
+          <a:xfrm>
+            <a:off x="548640" y="4343400"/>
+            <a:ext cx="640080" cy="640080"/>
+          </a:xfrm>
+          <a:prstGeom prst="ellipse">
+            <a:avLst/>
+          </a:prstGeom>
+          <a:solidFill>
+            <a:schemeClr val="accent1"/>
+          </a:solidFill>
+          <a:ln/>
+        </p:spPr>
+      </p:sp>
+      <p:sp>
+        <p:nvSpPr>
+          <p:cNvPr id="12" name="stepn-3"/>
+          <p:cNvSpPr txBox="1"/>
+          <p:nvPr/>
+        </p:nvSpPr>
+        <p:spPr>
+          <a:xfrm>
+            <a:off x="548640" y="4343400"/>
+            <a:ext cx="640080" cy="640080"/>
+          </a:xfrm>
+          <a:prstGeom prst="rect">
+            <a:avLst/>
+          </a:prstGeom>
+          <a:noFill/>
+          <a:ln/>
+        </p:spPr>
+        <p:txBody>
+          <a:bodyPr wrap="square" lIns="0" tIns="0" rIns="0" bIns="0" rtlCol="0" anchor="ctr"/>
+          <a:lstStyle/>
+          <a:p>
+            <a:pPr algn="ctr" indent="0" marL="0">
+              <a:buNone/>
+            </a:pPr>
+            <a:r>
+              <a:rPr lang="en-US" sz="2200" b="1" dirty="0">
+                <a:solidFill>
+                  <a:schemeClr val="bg1"/>
+                </a:solidFill>
+              </a:rPr>
+              <a:t>3</a:t>
+            </a:r>
+            <a:endParaRPr lang="en-US" sz="2200" dirty="0"/>
+          </a:p>
+        </p:txBody>
+      </p:sp>
+      <p:sp>
+        <p:nvSpPr>
+          <p:cNvPr id="13" name="stept-3"/>
+          <p:cNvSpPr txBox="1"/>
+          <p:nvPr/>
+        </p:nvSpPr>
+        <p:spPr>
+          <a:xfrm>
+            <a:off x="1371600" y="4297680"/>
+            <a:ext cx="3200400" cy="1188720"/>
+          </a:xfrm>
+          <a:prstGeom prst="rect">
+            <a:avLst/>
+          </a:prstGeom>
+          <a:noFill/>
+          <a:ln/>
+        </p:spPr>
+        <p:txBody>
+          <a:bodyPr wrap="square" lIns="0" tIns="0" rIns="0" bIns="0" rtlCol="0" anchor="t"/>
+          <a:lstStyle/>
+          <a:p>
+            <a:pPr indent="0" marL="0">
+              <a:buNone/>
+            </a:pPr>
+            <a:r>
+              <a:rPr lang="en-US" sz="1800" b="1" dirty="0">
+                <a:solidFill>
+                  <a:srgbClr val="000000"/>
+                </a:solidFill>
+              </a:rPr>
+              <a:t>Dillo a memoria</a:t>
+            </a:r>
+            <a:endParaRPr lang="en-US" sz="1800" dirty="0"/>
+          </a:p>
+          <a:p>
+            <a:pPr indent="0" marL="0">
+              <a:buNone/>
+            </a:pPr>
+            <a:r>
+              <a:rPr lang="en-US" sz="1400" dirty="0">
+                <a:solidFill>
+                  <a:srgbClr val="6B645D"/>
+                </a:solidFill>
+              </a:rPr>
+              <a:t>Il testo è nascosto: parti dalle parole chiave, poi controlla con "Mostra testo".</a:t>
+            </a:r>
+            <a:endParaRPr lang="en-US" sz="1800" dirty="0"/>
+          </a:p>
+        </p:txBody>
+      </p:sp>
+      <p:sp>
+        <p:nvSpPr>
+          <p:cNvPr id="25" name="Slide Number Placeholder 0"/>
+          <p:cNvSpPr>
+            <a:spLocks noGrp="1"/>
+          </p:cNvSpPr>
+          <p:nvPr>
+            <p:ph type="sldNum" sz="quarter" idx="4294967295"/>
+          </p:nvPr>
+        </p:nvSpPr>
+        <p:spPr>
+          <a:xfrm>
+            <a:off x="11430000" y="6400800"/>
+            <a:ext cx="457200" cy="274320"/>
+          </a:xfrm>
+          <a:prstGeom prst="rect">
+            <a:avLst/>
+          </a:prstGeom>
+          <a:extLst>
+            <a:ext uri="{C572A759-6A51-4108-AA02-DFA0A04FC94B}">
+              <ma14:wrappingTextBoxFlag xmlns:ma14="http://schemas.microsoft.com/office/mac/drawingml/2011/main" val="0"/>
+            </a:ext>
+          </a:extLst>
+        </p:spPr>
+        <p:txBody>
+          <a:bodyPr/>
+          <a:lstStyle>
+            <a:lvl1pPr>
+              <a:defRPr sz="1000">
+                <a:solidFill>
+                  <a:srgbClr val="6B645D"/>
+                </a:solidFill>
+              </a:defRPr>
+            </a:lvl1pPr>
+          </a:lstStyle>
+          <a:p>
+            <a:pPr algn="l"/>
+            <a:fld id="{F7021451-1387-4CA6-816F-3879F97B5CBC}" type="slidenum">
+              <a:rPr b="0" lang="en-US"/>
+              <a:t>11</a:t>
+            </a:fld>
+            <a:endParaRPr lang="en-US"/>
           </a:p>
         </p:txBody>
       </p:sp>
@@ -3135,7 +4008,7 @@
                   <a:srgbClr val="6B645D"/>
                 </a:solidFill>
               </a:rPr>
-              <a:t>Sono pagine HTML: si aprono nel browser, anche dal telefono.</a:t>
+              <a:t>Sono pagine HTML: si aprono nel browser, anche dal telefono. Per presentare il progetto c'è anche Il filo del discorso (slide 10).</a:t>
             </a:r>
             <a:endParaRPr lang="en-US" sz="1400" dirty="0"/>
           </a:p>
@@ -4805,7 +5678,7 @@
                   <a:srgbClr val="1F1A17"/>
                 </a:solidFill>
               </a:rPr>
-              <a:t>Le domande probabili, con traccia di risposta e post-it da citare.</a:t>
+              <a:t>Le domande probabili, con traccia e post-it da citare. Nuova area: Il filo del discorso.</a:t>
             </a:r>
             <a:endParaRPr lang="en-US" sz="1600" dirty="0"/>
           </a:p>

</xml_diff>